<commit_message>
Reprise: refreshed book, film and boards
</commit_message>
<xml_diff>
--- a/projet.pptx
+++ b/projet.pptx
@@ -1872,7 +1872,7 @@
               </a:defRPr>
             </a:pPr>
             <a:r>
-              <a:t>French / Français · individual entry</a:t>
+              <a:t>French nationality · individual entry</a:t>
             </a:r>
           </a:p>
         </p:txBody>
@@ -3077,7 +3077,7 @@
               </a:defRPr>
             </a:pPr>
             <a:r>
-              <a:t>French / Français · individual entry</a:t>
+              <a:t>French nationality · individual entry</a:t>
             </a:r>
           </a:p>
         </p:txBody>
@@ -3169,7 +3169,7 @@
         <p:spPr>
           <a:xfrm>
             <a:off x="310896" y="2834640"/>
-            <a:ext cx="3675887" cy="2249424"/>
+            <a:ext cx="3703320" cy="2578608"/>
           </a:xfrm>
           <a:prstGeom prst="rect">
             <a:avLst/>
@@ -3186,7 +3186,7 @@
               <a:spcAft>
                 <a:spcPts val="500"/>
               </a:spcAft>
-              <a:defRPr sz="1300" b="0">
+              <a:defRPr sz="1200" b="0">
                 <a:solidFill>
                   <a:srgbClr val="182329"/>
                 </a:solidFill>
@@ -3247,7 +3247,7 @@
         <p:spPr>
           <a:xfrm>
             <a:off x="4315968" y="2834640"/>
-            <a:ext cx="3675887" cy="2249424"/>
+            <a:ext cx="3703320" cy="2578608"/>
           </a:xfrm>
           <a:prstGeom prst="rect">
             <a:avLst/>
@@ -3264,7 +3264,7 @@
               <a:spcAft>
                 <a:spcPts val="500"/>
               </a:spcAft>
-              <a:defRPr sz="1300" b="0">
+              <a:defRPr sz="1200" b="0">
                 <a:solidFill>
                   <a:srgbClr val="182329"/>
                 </a:solidFill>

</xml_diff>

<commit_message>
Complete bilingual project site, engineering annex and reviewed QR-linked documents
</commit_message>
<xml_diff>
--- a/projet.pptx
+++ b/projet.pptx
@@ -2311,7 +2311,7 @@
               <a:spcAft>
                 <a:spcPts val="500"/>
               </a:spcAft>
-              <a:defRPr sz="1800" b="1">
+              <a:defRPr sz="1700" b="1">
                 <a:solidFill>
                   <a:srgbClr val="FFFFFF"/>
                 </a:solidFill>
@@ -2319,7 +2319,7 @@
               </a:defRPr>
             </a:pPr>
             <a:r>
-              <a:t>A culture of repair, towards a permanent human presence.</a:t>
+              <a:t>BIOMIMICRY / Renew the skin. Keep the frame in service.</a:t>
             </a:r>
           </a:p>
         </p:txBody>
@@ -3882,7 +3882,7 @@
               </a:defRPr>
             </a:pPr>
             <a:r>
-              <a:t>Film, books, A0 / marc-dvci.github.io/reprise</a:t>
+              <a:t>More details / marc-dvci.github.io/reprise</a:t>
             </a:r>
           </a:p>
         </p:txBody>

</xml_diff>